<commit_message>
Update Replikacija podataka (replication and mirroring) kod Firebird baze podataka.pptx
</commit_message>
<xml_diff>
--- a/seminarski-3/Replikacija podataka (replication and mirroring) kod Firebird baze podataka.pptx
+++ b/seminarski-3/Replikacija podataka (replication and mirroring) kod Firebird baze podataka.pptx
@@ -7328,66 +7328,7 @@
               <a:rPr lang="en-US" dirty="0" err="1"/>
               <a:t>tabelu</a:t>
             </a:r>
-            <a:r>
-              <a:rPr lang="en-US" dirty="0"/>
-              <a:t>, za </a:t>
-            </a:r>
-            <a:r>
-              <a:rPr lang="en-US" dirty="0" err="1"/>
-              <a:t>razliku</a:t>
-            </a:r>
-            <a:r>
-              <a:rPr lang="en-US" dirty="0"/>
-              <a:t> od </a:t>
-            </a:r>
-            <a:r>
-              <a:rPr lang="en-US" dirty="0" err="1"/>
-              <a:t>binarne</a:t>
-            </a:r>
-            <a:r>
-              <a:rPr lang="en-US" dirty="0"/>
-              <a:t> </a:t>
-            </a:r>
-            <a:r>
-              <a:rPr lang="en-US" dirty="0" err="1"/>
-              <a:t>replikacije</a:t>
-            </a:r>
-            <a:r>
-              <a:rPr lang="en-US" dirty="0"/>
-              <a:t> </a:t>
-            </a:r>
-            <a:r>
-              <a:rPr lang="en-US" dirty="0" err="1"/>
-              <a:t>koja</a:t>
-            </a:r>
-            <a:r>
-              <a:rPr lang="en-US" dirty="0"/>
-              <a:t> </a:t>
-            </a:r>
-            <a:r>
-              <a:rPr lang="en-US" dirty="0" err="1"/>
-              <a:t>kopira</a:t>
-            </a:r>
-            <a:r>
-              <a:rPr lang="en-US" dirty="0"/>
-              <a:t> </a:t>
-            </a:r>
-            <a:r>
-              <a:rPr lang="en-US" dirty="0" err="1"/>
-              <a:t>fizičke</a:t>
-            </a:r>
-            <a:r>
-              <a:rPr lang="en-US" dirty="0"/>
-              <a:t> </a:t>
-            </a:r>
-            <a:r>
-              <a:rPr lang="en-US" dirty="0" err="1"/>
-              <a:t>stranice</a:t>
-            </a:r>
-            <a:r>
-              <a:rPr lang="en-US" dirty="0"/>
-              <a:t>.</a:t>
-            </a:r>
+            <a:endParaRPr lang="en-US" dirty="0"/>
           </a:p>
           <a:p>
             <a:r>
@@ -7548,40 +7489,9 @@
             </a:r>
             <a:r>
               <a:rPr lang="en-US" dirty="0"/>
-              <a:t> PostgreSQL-a, </a:t>
-            </a:r>
-            <a:r>
-              <a:rPr lang="en-US" dirty="0" err="1"/>
-              <a:t>što</a:t>
-            </a:r>
-            <a:r>
-              <a:rPr lang="en-US" dirty="0"/>
-              <a:t> </a:t>
-            </a:r>
-            <a:r>
-              <a:rPr lang="en-US" dirty="0" err="1"/>
-              <a:t>binarnu</a:t>
-            </a:r>
-            <a:r>
-              <a:rPr lang="en-US" dirty="0"/>
-              <a:t> </a:t>
-            </a:r>
-            <a:r>
-              <a:rPr lang="en-US" dirty="0" err="1"/>
-              <a:t>replikaciju</a:t>
-            </a:r>
-            <a:r>
-              <a:rPr lang="en-US" dirty="0"/>
-              <a:t> ne </a:t>
-            </a:r>
-            <a:r>
-              <a:rPr lang="en-US" dirty="0" err="1"/>
-              <a:t>može</a:t>
-            </a:r>
-            <a:r>
-              <a:rPr lang="en-US" dirty="0"/>
-              <a:t>.</a:t>
-            </a:r>
+              <a:t> PostgreSQL-a</a:t>
+            </a:r>
+            <a:endParaRPr lang="sr-Latn-RS" dirty="0"/>
           </a:p>
           <a:p>
             <a:r>
@@ -18416,7 +18326,40 @@
                 <a:ea typeface="Calibri" pitchFamily="34" charset="-122"/>
                 <a:cs typeface="Calibri" pitchFamily="34" charset="-120"/>
               </a:rPr>
-              <a:t>Upis je UVEK sinhroni — baza ceka potvrdu OBA diska. Operise na nivou stranica (4–16 KB), ne SQL naredbi.</a:t>
+              <a:t>Upis je UVEK sinhroni — baza ceka potvrdu OBA diska. </a:t>
+            </a:r>
+            <a:r>
+              <a:rPr lang="en-US" sz="1400" b="1" dirty="0" err="1">
+                <a:solidFill>
+                  <a:srgbClr val="1B2A4A"/>
+                </a:solidFill>
+                <a:latin typeface="Calibri" pitchFamily="34" charset="0"/>
+                <a:ea typeface="Calibri" pitchFamily="34" charset="-122"/>
+                <a:cs typeface="Calibri" pitchFamily="34" charset="-120"/>
+              </a:rPr>
+              <a:t>Operi</a:t>
+            </a:r>
+            <a:r>
+              <a:rPr lang="sr-Latn-RS" sz="1400" b="1" dirty="0">
+                <a:solidFill>
+                  <a:srgbClr val="1B2A4A"/>
+                </a:solidFill>
+                <a:latin typeface="Calibri" pitchFamily="34" charset="0"/>
+                <a:ea typeface="Calibri" pitchFamily="34" charset="-122"/>
+                <a:cs typeface="Calibri" pitchFamily="34" charset="-120"/>
+              </a:rPr>
+              <a:t>š</a:t>
+            </a:r>
+            <a:r>
+              <a:rPr lang="en-US" sz="1400" b="1" dirty="0">
+                <a:solidFill>
+                  <a:srgbClr val="1B2A4A"/>
+                </a:solidFill>
+                <a:latin typeface="Calibri" pitchFamily="34" charset="0"/>
+                <a:ea typeface="Calibri" pitchFamily="34" charset="-122"/>
+                <a:cs typeface="Calibri" pitchFamily="34" charset="-120"/>
+              </a:rPr>
+              <a:t>e na nivou stranica (4–16 KB), ne SQL naredbi.</a:t>
             </a:r>
             <a:endParaRPr lang="en-US" sz="1400" b="1" dirty="0">
               <a:solidFill>
@@ -26080,7 +26023,40 @@
                 <a:ea typeface="Calibri" pitchFamily="34" charset="-122"/>
                 <a:cs typeface="Calibri" pitchFamily="34" charset="-120"/>
               </a:rPr>
-              <a:t>Nema SPOF — izuzetno visoka tolerancija na kvarove.</a:t>
+              <a:t>Nema </a:t>
+            </a:r>
+            <a:r>
+              <a:rPr lang="sr-Latn-RS" sz="1400">
+                <a:solidFill>
+                  <a:srgbClr val="475569"/>
+                </a:solidFill>
+                <a:latin typeface="Calibri" pitchFamily="34" charset="0"/>
+                <a:ea typeface="Calibri" pitchFamily="34" charset="-122"/>
+                <a:cs typeface="Calibri" pitchFamily="34" charset="-120"/>
+              </a:rPr>
+              <a:t>tačke kvara (SPOF)</a:t>
+            </a:r>
+            <a:r>
+              <a:rPr lang="en-US" sz="1400">
+                <a:solidFill>
+                  <a:srgbClr val="475569"/>
+                </a:solidFill>
+                <a:latin typeface="Calibri" pitchFamily="34" charset="0"/>
+                <a:ea typeface="Calibri" pitchFamily="34" charset="-122"/>
+                <a:cs typeface="Calibri" pitchFamily="34" charset="-120"/>
+              </a:rPr>
+              <a:t> </a:t>
+            </a:r>
+            <a:r>
+              <a:rPr lang="en-US" sz="1400" dirty="0">
+                <a:solidFill>
+                  <a:srgbClr val="475569"/>
+                </a:solidFill>
+                <a:latin typeface="Calibri" pitchFamily="34" charset="0"/>
+                <a:ea typeface="Calibri" pitchFamily="34" charset="-122"/>
+                <a:cs typeface="Calibri" pitchFamily="34" charset="-120"/>
+              </a:rPr>
+              <a:t>— izuzetno visoka tolerancija na kvarove.</a:t>
             </a:r>
             <a:endParaRPr lang="en-US" sz="1400" dirty="0"/>
           </a:p>

</xml_diff>